<commit_message>
Rename to The Trail: New Testament Edition
Co-Authored-By: Claude Opus 5.5 <noreply@anthropic.com>
Claude-Session: https://claude.ai/code/session_01PfFB4XdUdQRRjh4XT8DiXX
</commit_message>
<xml_diff>
--- a/slide-templates/The Trail Slide Templates.pptx
+++ b/slide-templates/The Trail Slide Templates.pptx
@@ -114,13 +114,13 @@
   <p:extLst>
     <p:ext uri="{521415D9-36F7-43E2-AB2F-B90AF26B5E84}">
       <p14:sectionLst xmlns:p14="http://schemas.microsoft.com/office/powerpoint/2010/main">
-        <p14:section name="Openers" id="{7f880dc2-8241-6853-9c76-576dd32aa288}">
+        <p14:section name="Openers" id="{d2e2243a-6105-aa8c-79e7-ea089fb84e61}">
           <p14:sldIdLst>
             <p14:sldId id="256"/>
             <p14:sldId id="257"/>
           </p14:sldIdLst>
         </p14:section>
-        <p14:section name="Teaching" id="{7df892eb-bae0-5691-8834-97df412ebe8d}">
+        <p14:section name="Teaching" id="{21892434-15b8-8312-c34a-f2e43c3e689c}">
           <p14:sldIdLst>
             <p14:sldId id="258"/>
             <p14:sldId id="259"/>
@@ -129,7 +129,7 @@
             <p14:sldId id="262"/>
           </p14:sldIdLst>
         </p14:section>
-        <p14:section name="Discussion" id="{7795c3c9-6e5e-f32d-1ac9-07c4ad94dfaa}">
+        <p14:section name="Discussion" id="{05f986d4-c01c-cbf9-937f-9af199bbbd12}">
           <p14:sldIdLst>
             <p14:sldId id="263"/>
           </p14:sldIdLst>
@@ -1322,7 +1322,7 @@
                   <a:schemeClr val="bg2"/>
                 </a:solidFill>
               </a:rPr>
-              <a:t>THE TRAIL · NEW TESTAMENT</a:t>
+              <a:t>THE TRAIL · NEW TESTAMENT EDITION</a:t>
             </a:r>
             <a:endParaRPr lang="en-US" sz="1400" dirty="0"/>
           </a:p>
@@ -2979,7 +2979,7 @@
                   <a:schemeClr val="bg2"/>
                 </a:solidFill>
               </a:rPr>
-              <a:t>THE TRAIL · NEW TESTAMENT</a:t>
+              <a:t>THE TRAIL · NEW TESTAMENT EDITION</a:t>
             </a:r>
             <a:endParaRPr lang="en-US" sz="1400" dirty="0"/>
           </a:p>

</xml_diff>